<commit_message>
Oprava prezentace: názvy obrázků bez diakritiky
PowerPoint nedokázal načíst obrázky pozadí, jejichž názvy uvnitř souboru
obsahovaly diakritiku, a při otevření hlásil chybu. Názvy jsou teď
bez diakritiky; rozložení snímků si ponechávají české názvy.

Co-Authored-By: Claude Opus 5.5 <noreply@anthropic.com>
Claude-Session: https://claude.ai/code/session_01Sg8Sy2Rv3HqxyBhd96rB2t
</commit_message>
<xml_diff>
--- a/zlinsky-kraj/Zlinsky_kraj.pptx
+++ b/zlinsky-kraj/Zlinsky_kraj.pptx
@@ -134,12 +134,12 @@
   <p:extLst>
     <p:ext uri="{521415D9-36F7-43E2-AB2F-B90AF26B5E84}">
       <p14:sectionLst xmlns:p14="http://schemas.microsoft.com/office/powerpoint/2010/main">
-        <p14:section name="Úvod" id="{470f97a5-c734-237a-a91a-0039a6672d3d}">
+        <p14:section name="Úvod" id="{2d125145-194f-9699-1aad-d484838c1840}">
           <p14:sldIdLst>
             <p14:sldId id="256"/>
           </p14:sldIdLst>
         </p14:section>
-        <p14:section name="Základní informace a příroda" id="{21da80a0-d7e6-0adb-2c71-f0a12a92a424}">
+        <p14:section name="Základní informace a příroda" id="{3b28d28f-1fe1-e3b9-16bb-8cea9c8d4be7}">
           <p14:sldIdLst>
             <p14:sldId id="257"/>
             <p14:sldId id="258"/>
@@ -147,7 +147,7 @@
             <p14:sldId id="260"/>
           </p14:sldIdLst>
         </p14:section>
-        <p14:section name="Historie, architektura a kultura" id="{b2974201-ce92-4afd-e699-132f33b72827}">
+        <p14:section name="Historie, architektura a kultura" id="{ce10d3ec-aea8-50f4-7b6f-c221c119b052}">
           <p14:sldIdLst>
             <p14:sldId id="261"/>
             <p14:sldId id="262"/>
@@ -156,7 +156,7 @@
             <p14:sldId id="265"/>
           </p14:sldIdLst>
         </p14:section>
-        <p14:section name="Turistika a sport" id="{7f431713-1a79-1628-6abf-cfedb802caf6}">
+        <p14:section name="Turistika a sport" id="{12069a40-85c1-a4a8-f92c-bf78dfbe8022}">
           <p14:sldIdLst>
             <p14:sldId id="266"/>
             <p14:sldId id="267"/>
@@ -164,13 +164,13 @@
             <p14:sldId id="269"/>
           </p14:sldIdLst>
         </p14:section>
-        <p14:section name="Závěr a zdroje" id="{bcb7f425-edb3-0687-7358-d3a608e3bdb9}">
+        <p14:section name="Závěr a zdroje" id="{2e8e0c17-fa7d-183c-e74a-10a7b2c5a2e7}">
           <p14:sldIdLst>
             <p14:sldId id="270"/>
             <p14:sldId id="271"/>
           </p14:sldIdLst>
         </p14:section>
-        <p14:section name="Kvíz" id="{4c1a5326-8e5c-e930-2965-d5febec466ba}">
+        <p14:section name="Kvíz" id="{e62444cb-ec76-ab46-02b1-a624764819f5}">
           <p14:sldIdLst>
             <p14:sldId id="272"/>
             <p14:sldId id="273"/>

</xml_diff>